<commit_message>
BCMOHAM-32795-V1 || Correected the extra spacing at the date
</commit_message>
<xml_diff>
--- a/ALR-DocgenTemplates/CertificateBackground_SU.pptx
+++ b/ALR-DocgenTemplates/CertificateBackground_SU.pptx
@@ -112,35 +112,6 @@
 </p:presentation>
 </file>
 
-<file path=ppt/changesInfos/changesInfo1.xml><?xml version="1.0" encoding="utf-8"?>
-<pc:chgInfo xmlns:a="http://schemas.openxmlformats.org/drawingml/2006/main" xmlns:r="http://schemas.openxmlformats.org/officeDocument/2006/relationships" xmlns:ac="http://schemas.microsoft.com/office/drawing/2013/main/command" xmlns:pc="http://schemas.microsoft.com/office/powerpoint/2013/main/command">
-  <pc:docChgLst>
-    <pc:chgData name="Narendra Patil, Kiran" userId="bd8726b3-9de5-4981-82ea-44e4ceaf49c4" providerId="ADAL" clId="{AEC3F5A0-79AE-4B5E-8160-C5BDCC55510A}"/>
-    <pc:docChg chg="modSld">
-      <pc:chgData name="Narendra Patil, Kiran" userId="bd8726b3-9de5-4981-82ea-44e4ceaf49c4" providerId="ADAL" clId="{AEC3F5A0-79AE-4B5E-8160-C5BDCC55510A}" dt="2024-08-07T10:09:43.513" v="8" actId="20577"/>
-      <pc:docMkLst>
-        <pc:docMk/>
-      </pc:docMkLst>
-      <pc:sldChg chg="modSp mod">
-        <pc:chgData name="Narendra Patil, Kiran" userId="bd8726b3-9de5-4981-82ea-44e4ceaf49c4" providerId="ADAL" clId="{AEC3F5A0-79AE-4B5E-8160-C5BDCC55510A}" dt="2024-08-07T10:09:43.513" v="8" actId="20577"/>
-        <pc:sldMkLst>
-          <pc:docMk/>
-          <pc:sldMk cId="1830213082" sldId="256"/>
-        </pc:sldMkLst>
-        <pc:spChg chg="mod">
-          <ac:chgData name="Narendra Patil, Kiran" userId="bd8726b3-9de5-4981-82ea-44e4ceaf49c4" providerId="ADAL" clId="{AEC3F5A0-79AE-4B5E-8160-C5BDCC55510A}" dt="2024-08-07T10:09:43.513" v="8" actId="20577"/>
-          <ac:spMkLst>
-            <pc:docMk/>
-            <pc:sldMk cId="1830213082" sldId="256"/>
-            <ac:spMk id="9" creationId="{2661C2CE-7AAD-2E59-A527-EDBEF23061BD}"/>
-          </ac:spMkLst>
-        </pc:spChg>
-      </pc:sldChg>
-    </pc:docChg>
-  </pc:docChgLst>
-</pc:chgInfo>
-</file>
-
 <file path=ppt/slideLayouts/slideLayout1.xml><?xml version="1.0" encoding="utf-8"?>
 <p:sldLayout xmlns:a="http://schemas.openxmlformats.org/drawingml/2006/main" xmlns:r="http://schemas.openxmlformats.org/officeDocument/2006/relationships" xmlns:p="http://schemas.openxmlformats.org/presentationml/2006/main" type="title" preserve="1">
   <p:cSld name="Title Slide">
@@ -272,7 +243,7 @@
           <a:p>
             <a:fld id="{E0C45857-5204-4055-BBBB-5D81F6C0DEE1}" type="datetimeFigureOut">
               <a:rPr lang="en-US" smtClean="0"/>
-              <a:t>7/29/2026</a:t>
+              <a:t>7/31/2026</a:t>
             </a:fld>
             <a:endParaRPr lang="en-US"/>
           </a:p>
@@ -442,7 +413,7 @@
           <a:p>
             <a:fld id="{E0C45857-5204-4055-BBBB-5D81F6C0DEE1}" type="datetimeFigureOut">
               <a:rPr lang="en-US" smtClean="0"/>
-              <a:t>7/29/2026</a:t>
+              <a:t>7/31/2026</a:t>
             </a:fld>
             <a:endParaRPr lang="en-US"/>
           </a:p>
@@ -622,7 +593,7 @@
           <a:p>
             <a:fld id="{E0C45857-5204-4055-BBBB-5D81F6C0DEE1}" type="datetimeFigureOut">
               <a:rPr lang="en-US" smtClean="0"/>
-              <a:t>7/29/2026</a:t>
+              <a:t>7/31/2026</a:t>
             </a:fld>
             <a:endParaRPr lang="en-US"/>
           </a:p>
@@ -792,7 +763,7 @@
           <a:p>
             <a:fld id="{E0C45857-5204-4055-BBBB-5D81F6C0DEE1}" type="datetimeFigureOut">
               <a:rPr lang="en-US" smtClean="0"/>
-              <a:t>7/29/2026</a:t>
+              <a:t>7/31/2026</a:t>
             </a:fld>
             <a:endParaRPr lang="en-US"/>
           </a:p>
@@ -1036,7 +1007,7 @@
           <a:p>
             <a:fld id="{E0C45857-5204-4055-BBBB-5D81F6C0DEE1}" type="datetimeFigureOut">
               <a:rPr lang="en-US" smtClean="0"/>
-              <a:t>7/29/2026</a:t>
+              <a:t>7/31/2026</a:t>
             </a:fld>
             <a:endParaRPr lang="en-US"/>
           </a:p>
@@ -1268,7 +1239,7 @@
           <a:p>
             <a:fld id="{E0C45857-5204-4055-BBBB-5D81F6C0DEE1}" type="datetimeFigureOut">
               <a:rPr lang="en-US" smtClean="0"/>
-              <a:t>7/29/2026</a:t>
+              <a:t>7/31/2026</a:t>
             </a:fld>
             <a:endParaRPr lang="en-US"/>
           </a:p>
@@ -1635,7 +1606,7 @@
           <a:p>
             <a:fld id="{E0C45857-5204-4055-BBBB-5D81F6C0DEE1}" type="datetimeFigureOut">
               <a:rPr lang="en-US" smtClean="0"/>
-              <a:t>7/29/2026</a:t>
+              <a:t>7/31/2026</a:t>
             </a:fld>
             <a:endParaRPr lang="en-US"/>
           </a:p>
@@ -1753,7 +1724,7 @@
           <a:p>
             <a:fld id="{E0C45857-5204-4055-BBBB-5D81F6C0DEE1}" type="datetimeFigureOut">
               <a:rPr lang="en-US" smtClean="0"/>
-              <a:t>7/29/2026</a:t>
+              <a:t>7/31/2026</a:t>
             </a:fld>
             <a:endParaRPr lang="en-US"/>
           </a:p>
@@ -1848,7 +1819,7 @@
           <a:p>
             <a:fld id="{E0C45857-5204-4055-BBBB-5D81F6C0DEE1}" type="datetimeFigureOut">
               <a:rPr lang="en-US" smtClean="0"/>
-              <a:t>7/29/2026</a:t>
+              <a:t>7/31/2026</a:t>
             </a:fld>
             <a:endParaRPr lang="en-US"/>
           </a:p>
@@ -2125,7 +2096,7 @@
           <a:p>
             <a:fld id="{E0C45857-5204-4055-BBBB-5D81F6C0DEE1}" type="datetimeFigureOut">
               <a:rPr lang="en-US" smtClean="0"/>
-              <a:t>7/29/2026</a:t>
+              <a:t>7/31/2026</a:t>
             </a:fld>
             <a:endParaRPr lang="en-US"/>
           </a:p>
@@ -2382,7 +2353,7 @@
           <a:p>
             <a:fld id="{E0C45857-5204-4055-BBBB-5D81F6C0DEE1}" type="datetimeFigureOut">
               <a:rPr lang="en-US" smtClean="0"/>
-              <a:t>7/29/2026</a:t>
+              <a:t>7/31/2026</a:t>
             </a:fld>
             <a:endParaRPr lang="en-US"/>
           </a:p>
@@ -2595,7 +2566,7 @@
           <a:p>
             <a:fld id="{E0C45857-5204-4055-BBBB-5D81F6C0DEE1}" type="datetimeFigureOut">
               <a:rPr lang="en-US" smtClean="0"/>
-              <a:t>7/29/2026</a:t>
+              <a:t>7/31/2026</a:t>
             </a:fld>
             <a:endParaRPr lang="en-US"/>
           </a:p>
@@ -3792,7 +3763,7 @@
           <a:lstStyle/>
           <a:p>
             <a:r>
-              <a:rPr lang="en-US" sz="1400" b="1" dirty="0">
+              <a:rPr lang="en-US" sz="1400" b="1">
                 <a:solidFill>
                   <a:srgbClr val="3B305B"/>
                 </a:solidFill>
@@ -3800,7 +3771,7 @@
                 <a:ea typeface="Verdana" panose="020B0604030504040204" pitchFamily="34" charset="0"/>
                 <a:cs typeface="Verdana" panose="020B0604030504040204" pitchFamily="34" charset="0"/>
               </a:rPr>
-              <a:t>  {{</a:t>
+              <a:t>   {{</a:t>
             </a:r>
             <a:r>
               <a:rPr lang="en-US" sz="1400" b="1" dirty="0" err="1">

</xml_diff>